<commit_message>
Record the verified platform run in the docs, report and deck
</commit_message>
<xml_diff>
--- a/deliverables/FraudLens_Final_Presentation.pptx
+++ b/deliverables/FraudLens_Final_Presentation.pptx
@@ -119,38 +119,38 @@
   <p:extLst>
     <p:ext uri="{521415D9-36F7-43E2-AB2F-B90AF26B5E84}">
       <p14:sectionLst xmlns:p14="http://schemas.microsoft.com/office/powerpoint/2010/main">
-        <p14:section name="Introduction" id="{9f492719-9010-21c1-3423-74425cf127e6}">
+        <p14:section name="Introduction" id="{87807d6b-ee70-c5dd-3a90-866b8747e637}">
           <p14:sldIdLst>
             <p14:sldId id="256"/>
             <p14:sldId id="257"/>
           </p14:sldIdLst>
         </p14:section>
-        <p14:section name="Lifecycle" id="{798403b1-fe00-eea5-18fa-8769066bdc37}">
+        <p14:section name="Lifecycle" id="{1058019c-6fcf-98a1-b5af-185f38a75bdf}">
           <p14:sldIdLst>
             <p14:sldId id="258"/>
             <p14:sldId id="259"/>
           </p14:sldIdLst>
         </p14:section>
-        <p14:section name="Data" id="{3db383e8-3bc6-c836-5a6c-cba5aa1397c1}">
+        <p14:section name="Data" id="{e7413129-4cb1-142b-ead0-044d44a2f9bb}">
           <p14:sldIdLst>
             <p14:sldId id="260"/>
             <p14:sldId id="261"/>
           </p14:sldIdLst>
         </p14:section>
-        <p14:section name="Modelling" id="{7cd1d320-278c-9899-780c-7bc235e775d4}">
+        <p14:section name="Modelling" id="{2e690450-69cf-1db4-5a20-c4ed1d24b8ce}">
           <p14:sldIdLst>
             <p14:sldId id="262"/>
             <p14:sldId id="263"/>
             <p14:sldId id="264"/>
           </p14:sldIdLst>
         </p14:section>
-        <p14:section name="Deployment" id="{c27b7ed6-1156-ac05-994a-8d2579a3f33f}">
+        <p14:section name="Deployment" id="{c0cef160-9aef-f33b-d86b-57d4df03713f}">
           <p14:sldIdLst>
             <p14:sldId id="265"/>
             <p14:sldId id="266"/>
           </p14:sldIdLst>
         </p14:section>
-        <p14:section name="Close" id="{b62d7a48-dcd8-ef89-85a6-5bdc1c11e031}">
+        <p14:section name="Close" id="{8b979070-d1b0-c023-b009-a7da40e51f5a}">
           <p14:sldIdLst>
             <p14:sldId id="267"/>
             <p14:sldId id="268"/>
@@ -2529,7 +2529,7 @@
           <a:p>
             <a:r>
               <a:rPr lang="en-US" dirty="0"/>
-              <a:t>The project is run like a product. The GitHub Project board is generated from a plan file, with milestones and an issue per task, and a lifecycle-stage field so progress is visible stage by stage. Three workflows test the lifecycle, the whole Docker platform, and the deployable image. Fifty-six verification checks pass, including a train-to-serve parity test that caught a real precision bug during the final run.</a:t>
+              <a:t>The project is run like a product. The GitHub Project board is generated from a plan file, with milestones and an issue per task, and a lifecycle-stage field so progress is visible stage by stage. Three workflows test the lifecycle, the whole Docker platform, and the deployable image. On the runner every platform service starts, the sample lifecycle flows from NiFi through the lake, Trino and ClickHouse, and 14 of 14 smoke checks pass; OpenMetadata catalogues 13 tables with 29 PII-tagged columns and lineage. Fifty-six verification checks pass, including a train-to-serve parity test that caught a real precision bug during the final run.</a:t>
             </a:r>
             <a:endParaRPr lang="en-US" dirty="0"/>
           </a:p>
@@ -4163,7 +4163,7 @@
       </p:sp>
       <p:pic>
         <p:nvPicPr>
-          <p:cNvPr id="3" name="dashboard_live_scoring.png" descr="/home/claude/fraudlens/docs/images/dashboard_live_scoring.png">    </p:cNvPr>
+          <p:cNvPr id="3" name="dashboard_live_scoring.png" descr="/home/claude/repo/docs/images/dashboard_live_scoring.png">    </p:cNvPr>
           <p:cNvPicPr>
             <a:picLocks noChangeAspect="1"/>
           </p:cNvPicPr>
@@ -4964,7 +4964,7 @@
                   <a:schemeClr val="tx1"/>
                 </a:solidFill>
               </a:rPr>
-              <a:t>platform: Docker stack end to end, smoke tests</a:t>
+              <a:t>platform: Docker stack end to end, 14/14 smoke checks pass</a:t>
             </a:r>
             <a:endParaRPr lang="en-US" sz="1300" dirty="0"/>
           </a:p>
@@ -7440,7 +7440,7 @@
       </p:sp>
       <p:pic>
         <p:nvPicPr>
-          <p:cNvPr id="3" name="architecture.png" descr="/home/claude/fraudlens/docs/images/architecture.png">    </p:cNvPr>
+          <p:cNvPr id="3" name="architecture.png" descr="/home/claude/repo/docs/images/architecture.png">    </p:cNvPr>
           <p:cNvPicPr>
             <a:picLocks noChangeAspect="1"/>
           </p:cNvPicPr>
@@ -8357,7 +8357,7 @@
       </p:sp>
       <p:pic>
         <p:nvPicPr>
-          <p:cNvPr id="15" name="eda-category" descr="/tmp/claude-0/rep/figures/03_fraud_by_category.png">    </p:cNvPr>
+          <p:cNvPr id="15" name="eda-category" descr="reports/figures/03_fraud_by_category.png">    </p:cNvPr>
           <p:cNvPicPr>
             <a:picLocks noChangeAspect="1"/>
           </p:cNvPicPr>

</xml_diff>

<commit_message>
Point docs and report at the rewritten commit ids
</commit_message>
<xml_diff>
--- a/deliverables/FraudLens_Final_Presentation.pptx
+++ b/deliverables/FraudLens_Final_Presentation.pptx
@@ -119,38 +119,38 @@
   <p:extLst>
     <p:ext uri="{521415D9-36F7-43E2-AB2F-B90AF26B5E84}">
       <p14:sectionLst xmlns:p14="http://schemas.microsoft.com/office/powerpoint/2010/main">
-        <p14:section name="Introduction" id="{87807d6b-ee70-c5dd-3a90-866b8747e637}">
+        <p14:section name="Introduction" id="{5f70b13b-1aed-4e23-0796-7210dd1b3232}">
           <p14:sldIdLst>
             <p14:sldId id="256"/>
             <p14:sldId id="257"/>
           </p14:sldIdLst>
         </p14:section>
-        <p14:section name="Lifecycle" id="{1058019c-6fcf-98a1-b5af-185f38a75bdf}">
+        <p14:section name="Lifecycle" id="{6fc6cac9-98d7-c2cf-1f4d-7626d406491f}">
           <p14:sldIdLst>
             <p14:sldId id="258"/>
             <p14:sldId id="259"/>
           </p14:sldIdLst>
         </p14:section>
-        <p14:section name="Data" id="{e7413129-4cb1-142b-ead0-044d44a2f9bb}">
+        <p14:section name="Data" id="{187387aa-4b1e-6fdd-8ab3-7340341091ea}">
           <p14:sldIdLst>
             <p14:sldId id="260"/>
             <p14:sldId id="261"/>
           </p14:sldIdLst>
         </p14:section>
-        <p14:section name="Modelling" id="{2e690450-69cf-1db4-5a20-c4ed1d24b8ce}">
+        <p14:section name="Modelling" id="{496706e9-e555-3214-095d-8731e514c017}">
           <p14:sldIdLst>
             <p14:sldId id="262"/>
             <p14:sldId id="263"/>
             <p14:sldId id="264"/>
           </p14:sldIdLst>
         </p14:section>
-        <p14:section name="Deployment" id="{c0cef160-9aef-f33b-d86b-57d4df03713f}">
+        <p14:section name="Deployment" id="{1c7e6add-a177-8a26-ca33-7dde2bc66b08}">
           <p14:sldIdLst>
             <p14:sldId id="265"/>
             <p14:sldId id="266"/>
           </p14:sldIdLst>
         </p14:section>
-        <p14:section name="Close" id="{8b979070-d1b0-c023-b009-a7da40e51f5a}">
+        <p14:section name="Close" id="{487bad94-476d-d66e-36bf-8836beb55424}">
           <p14:sldIdLst>
             <p14:sldId id="267"/>
             <p14:sldId id="268"/>

</xml_diff>

<commit_message>
Supervisor feedback: live decision path, analyst workflow, access control, stability and transferability
- Every scored transaction becomes a case; alerts wait in a review queue (API /alerts, dashboard Case review)
- Analyst decisions are audited and feed live monitoring (live precision vs floor, backlog) and retraining data
- Role-based API keys and a dashboard sign-in; Prometheus rules for low live precision, backlog, refused calls
- Net benefit shown as an estimate under stated review-cost and recovery assumptions
- Monthly stability with Wilson intervals, precision under other fraud rates, SHAP faithfulness checks, counterfactual amounts
- Docs, report, deck and notebooks 07-08 updated
</commit_message>
<xml_diff>
--- a/deliverables/FraudLens_Final_Presentation.pptx
+++ b/deliverables/FraudLens_Final_Presentation.pptx
@@ -18,9 +18,10 @@
     <p:sldId id="266" r:id="rId12"/>
     <p:sldId id="267" r:id="rId13"/>
     <p:sldId id="268" r:id="rId14"/>
+    <p:sldId id="269" r:id="rId15"/>
   </p:sldIdLst>
   <p:notesMasterIdLst>
-    <p:notesMasterId r:id="rId15"/>
+    <p:notesMasterId r:id="rId16"/>
   </p:notesMasterIdLst>
   <p:sldSz cx="9144000" cy="5143500"/>
   <p:notesSz cx="5143500" cy="9144000"/>
@@ -119,41 +120,42 @@
   <p:extLst>
     <p:ext uri="{521415D9-36F7-43E2-AB2F-B90AF26B5E84}">
       <p14:sectionLst xmlns:p14="http://schemas.microsoft.com/office/powerpoint/2010/main">
-        <p14:section name="Introduction" id="{5f70b13b-1aed-4e23-0796-7210dd1b3232}">
+        <p14:section name="Introduction" id="{dd48119a-b47d-00c1-c672-3dbf2897934b}">
           <p14:sldIdLst>
             <p14:sldId id="256"/>
             <p14:sldId id="257"/>
           </p14:sldIdLst>
         </p14:section>
-        <p14:section name="Lifecycle" id="{6fc6cac9-98d7-c2cf-1f4d-7626d406491f}">
+        <p14:section name="Lifecycle" id="{e1af44ad-0133-8656-9a51-f51112441a9e}">
           <p14:sldIdLst>
             <p14:sldId id="258"/>
             <p14:sldId id="259"/>
           </p14:sldIdLst>
         </p14:section>
-        <p14:section name="Data" id="{187387aa-4b1e-6fdd-8ab3-7340341091ea}">
+        <p14:section name="Data" id="{7f094d91-b99d-5b9d-14aa-9d2888f43a4f}">
           <p14:sldIdLst>
             <p14:sldId id="260"/>
             <p14:sldId id="261"/>
           </p14:sldIdLst>
         </p14:section>
-        <p14:section name="Modelling" id="{496706e9-e555-3214-095d-8731e514c017}">
+        <p14:section name="Modelling" id="{39648895-9898-5f12-436f-83090ccdfe7a}">
           <p14:sldIdLst>
             <p14:sldId id="262"/>
             <p14:sldId id="263"/>
             <p14:sldId id="264"/>
           </p14:sldIdLst>
         </p14:section>
-        <p14:section name="Deployment" id="{1c7e6add-a177-8a26-ca33-7dde2bc66b08}">
+        <p14:section name="Deployment" id="{bd56bf68-97a7-2834-2af4-da6f4ca76afe}">
           <p14:sldIdLst>
             <p14:sldId id="265"/>
             <p14:sldId id="266"/>
+            <p14:sldId id="267"/>
           </p14:sldIdLst>
         </p14:section>
-        <p14:section name="Close" id="{487bad94-476d-d66e-36bf-8836beb55424}">
+        <p14:section name="Close" id="{d3d4c99e-2a51-df44-f8c8-c2b0f4e20a4e}">
           <p14:sldIdLst>
-            <p14:sldId id="267"/>
             <p14:sldId id="268"/>
+            <p14:sldId id="269"/>
           </p14:sldIdLst>
         </p14:section>
       </p14:sectionLst>
@@ -2441,7 +2443,7 @@
           <a:p>
             <a:r>
               <a:rPr lang="en-US" dirty="0"/>
-              <a:t>Monitoring replays the scored months as if the model were live. Evidently measures drift against the training data; performance is measured at the fixed threshold. The policy flagged August and December, driven by seasonal spending, while recall stayed above the floor, so a person reviews the recommendation. A challenger retrained on more recent data scores slightly higher and would be promoted through the MLflow registry alias. In operation, Prometheus and Grafana watch the API and analyst feedback provides new labels.</a:t>
+              <a:t>This answers the main question from the last review: what happens to a transaction we have never seen. It arrives at the scoring API, or here in the dashboard, which runs the same code. The online feature store computes its card-history features from the card's earlier transactions. The champion scores it, SHAP explains the score, and for an alert we also show the amount at which it would have been approved. An alert opens a case in the review queue; the analyst sees exactly what the model saw and records fraud or legitimate, with their name in the audit log. Those decisions are labels: live precision is tracked against the policy floor and alerts in Prometheus if it drops, disputes on approved transactions count as misses, and every decided case becomes a training example for the next model. Access is controlled throughout: API keys by role and a dashboard sign-in where only analysts can decide.</a:t>
             </a:r>
             <a:endParaRPr lang="en-US" dirty="0"/>
           </a:p>
@@ -2529,7 +2531,7 @@
           <a:p>
             <a:r>
               <a:rPr lang="en-US" dirty="0"/>
-              <a:t>The project is run like a product. The GitHub Project board is generated from a plan file, with milestones and an issue per task, and a lifecycle-stage field so progress is visible stage by stage. Three workflows test the lifecycle, the whole Docker platform, and the deployable image. On the runner every platform service starts, the sample lifecycle flows from NiFi through the lake, Trino and ClickHouse, and 14 of 14 smoke checks pass; OpenMetadata catalogues 13 tables with 29 PII-tagged columns and lineage. Fifty-six verification checks pass, including a train-to-serve parity test that caught a real precision bug during the final run.</a:t>
+              <a:t>Monitoring replays the scored months as if the model were live. Evidently measures drift against the training data; performance is measured at the fixed threshold. The policy flagged August and December, driven by seasonal spending, while recall stayed above the floor, so a person reviews the recommendation. A challenger retrained on more recent data scores slightly higher and would be promoted through the MLflow registry alias. In operation, Prometheus and Grafana watch the API and analyst feedback provides new labels.</a:t>
             </a:r>
             <a:endParaRPr lang="en-US" dirty="0"/>
           </a:p>
@@ -2617,7 +2619,7 @@
           <a:p>
             <a:r>
               <a:rPr lang="en-US" dirty="0"/>
-              <a:t>To conclude: FraudLens meets all five objectives, from data collection to a monitored deployment, on open-source tools. The limitation to keep in mind is that the data are simulated, so the numbers validate the method rather than predict production accuracy. Next steps are real data, calibrated probabilities and a scheduled retraining loop. Thank you; we are happy to take questions.</a:t>
+              <a:t>The project is run like a product. The GitHub Project board is generated from a plan file, with milestones and an issue per task, and a lifecycle-stage field so progress is visible stage by stage. Three workflows test the lifecycle, the whole Docker platform, and the deployable image. On the runner every platform service starts, the sample lifecycle flows from NiFi through the lake, Trino and ClickHouse, and 14 of 14 smoke checks pass; OpenMetadata catalogues 13 tables with 29 PII-tagged columns and lineage. Fifty-six verification checks pass, including a train-to-serve parity test that caught a real precision bug during the final run.</a:t>
             </a:r>
             <a:endParaRPr lang="en-US" dirty="0"/>
           </a:p>
@@ -2641,6 +2643,94 @@
             <a:fld id="{F7021451-1387-4CA6-816F-3879F97B5CBC}" type="slidenum">
               <a:rPr lang="en-US"/>
               <a:t>13</a:t>
+            </a:fld>
+            <a:endParaRPr lang="en-US"/>
+          </a:p>
+        </p:txBody>
+      </p:sp>
+    </p:spTree>
+    <p:extLst>
+      <p:ext uri="{BB962C8B-B14F-4D97-AF65-F5344CB8AC3E}">
+        <p14:creationId xmlns:p14="http://schemas.microsoft.com/office/powerpoint/2010/main" val="1024086991"/>
+      </p:ext>
+    </p:extLst>
+  </p:cSld>
+  <p:clrMapOvr>
+    <a:masterClrMapping/>
+  </p:clrMapOvr>
+</p:notes>
+</file>
+
+<file path=ppt/notesSlides/notesSlide14.xml><?xml version="1.0" encoding="utf-8"?>
+<p:notes xmlns:a="http://schemas.openxmlformats.org/drawingml/2006/main" xmlns:r="http://schemas.openxmlformats.org/officeDocument/2006/relationships" xmlns:p="http://schemas.openxmlformats.org/presentationml/2006/main">
+  <p:cSld>
+    <p:spTree>
+      <p:nvGrpSpPr>
+        <p:cNvPr id="1" name=""/>
+        <p:cNvGrpSpPr/>
+        <p:nvPr/>
+      </p:nvGrpSpPr>
+      <p:grpSpPr>
+        <a:xfrm>
+          <a:off x="0" y="0"/>
+          <a:ext cx="0" cy="0"/>
+          <a:chOff x="0" y="0"/>
+          <a:chExt cx="0" cy="0"/>
+        </a:xfrm>
+      </p:grpSpPr>
+      <p:sp>
+        <p:nvSpPr>
+          <p:cNvPr id="2" name="Slide Image Placeholder 1"/>
+          <p:cNvSpPr>
+            <a:spLocks noGrp="1" noRot="1" noChangeAspect="1"/>
+          </p:cNvSpPr>
+          <p:nvPr>
+            <p:ph type="sldImg"/>
+          </p:nvPr>
+        </p:nvSpPr>
+        <p:spPr/>
+      </p:sp>
+      <p:sp>
+        <p:nvSpPr>
+          <p:cNvPr id="3" name="Notes Placeholder 2"/>
+          <p:cNvSpPr>
+            <a:spLocks noGrp="1"/>
+          </p:cNvSpPr>
+          <p:nvPr>
+            <p:ph type="body" idx="1"/>
+          </p:nvPr>
+        </p:nvSpPr>
+        <p:spPr/>
+        <p:txBody>
+          <a:bodyPr/>
+          <a:lstStyle/>
+          <a:p>
+            <a:r>
+              <a:rPr lang="en-US" dirty="0"/>
+              <a:t>To conclude: FraudLens meets all five objectives, from data collection to a monitored deployment, on open-source tools. The limitation to keep in mind is that the data are simulated, so the numbers validate the method rather than predict production accuracy. Next steps are real data, calibrated probabilities and a scheduled retraining loop. Thank you; we are happy to take questions.</a:t>
+            </a:r>
+            <a:endParaRPr lang="en-US" dirty="0"/>
+          </a:p>
+        </p:txBody>
+      </p:sp>
+      <p:sp>
+        <p:nvSpPr>
+          <p:cNvPr id="4" name="Slide Number Placeholder 3"/>
+          <p:cNvSpPr>
+            <a:spLocks noGrp="1"/>
+          </p:cNvSpPr>
+          <p:nvPr>
+            <p:ph type="sldNum" sz="quarter" idx="10"/>
+          </p:nvPr>
+        </p:nvSpPr>
+        <p:spPr/>
+        <p:txBody>
+          <a:bodyPr/>
+          <a:lstStyle/>
+          <a:p>
+            <a:fld id="{F7021451-1387-4CA6-816F-3879F97B5CBC}" type="slidenum">
+              <a:rPr lang="en-US"/>
+              <a:t>14</a:t>
             </a:fld>
             <a:endParaRPr lang="en-US"/>
           </a:p>
@@ -2705,7 +2795,7 @@
           <a:p>
             <a:r>
               <a:rPr lang="en-US" dirty="0"/>
-              <a:t>The business problem is a trade-off: catch fraud, but keep the analysts' queue small and trustworthy. We wrote four success criteria into the configuration before any model was trained. On the six months of test data the champion catches 96.2% of fraud with 72.4% precision at 14.7 alerts a day. In money terms that is about $964,182 net benefit. Accuracy is not on the slide on purpose: never alerting would be 99.6% accurate.</a:t>
+              <a:t>The business problem is a trade-off: catch fraud, but keep the analysts' queue small and trustworthy. We wrote four success criteria into the configuration before any model was trained. On the six months of test data the champion catches 96.2% of fraud with 72.4% precision at 14.7 alerts a day. In money terms that is an estimated $964,182 net benefit, but note the word estimated: it assumes a review costs fifteen dollars and that ninety percent of caught fraud value is recovered, on simulated data. It ranks operating points; real savings would have to be measured in a trial. Accuracy is not on the slide on purpose: never alerting would be 99.6% accurate.</a:t>
             </a:r>
             <a:endParaRPr lang="en-US" dirty="0"/>
           </a:p>
@@ -4219,7 +4309,7 @@
                   <a:schemeClr val="tx1"/>
                 </a:solidFill>
               </a:rPr>
-              <a:t>FastAPI /score: online feature store computes card history in real time; SHAP reasons; /feedback; /metrics</a:t>
+              <a:t>FastAPI /score: online feature store computes card history in real time; SHAP reasons and a counterfactual</a:t>
             </a:r>
             <a:endParaRPr lang="en-US" sz="1200" dirty="0"/>
           </a:p>
@@ -4237,7 +4327,7 @@
                   <a:schemeClr val="tx1"/>
                 </a:solidFill>
               </a:rPr>
-              <a:t>Streamlit: alert queue, live scoring, threshold &amp; cost what-if, monitoring, report</a:t>
+              <a:t>Review queue: /alerts and /alerts/{id}/decision; the dashboard's Case review tab</a:t>
             </a:r>
             <a:endParaRPr lang="en-US" sz="1200" dirty="0"/>
           </a:p>
@@ -4255,7 +4345,7 @@
                   <a:schemeClr val="tx1"/>
                 </a:solidFill>
               </a:rPr>
-              <a:t>One 40 MB bundle: model + threshold + feature store; container image ghcr.io/…/fraudlens-app</a:t>
+              <a:t>Access control: role-based API keys (scorer, analyst, admin); dashboard sign-in (analyst, viewer); audit log</a:t>
             </a:r>
             <a:endParaRPr lang="en-US" sz="1200" dirty="0"/>
           </a:p>
@@ -4273,7 +4363,7 @@
                   <a:schemeClr val="tx1"/>
                 </a:solidFill>
               </a:rPr>
-              <a:t>Deployed with public links; hosted option: Streamlit Community Cloud from the repository</a:t>
+              <a:t>One 40 MB bundle; container image ghcr.io/…/fraudlens-app; public links with access control on</a:t>
             </a:r>
             <a:endParaRPr lang="en-US" sz="1200" dirty="0"/>
           </a:p>
@@ -4384,78 +4474,26 @@
                 <a:ea typeface="Cambria" pitchFamily="34" charset="-122"/>
                 <a:cs typeface="Cambria" pitchFamily="34" charset="-120"/>
               </a:rPr>
-              <a:t>Monitoring closes the loop</a:t>
+              <a:t>A new transaction, from features to an analyst decision</a:t>
             </a:r>
             <a:endParaRPr lang="en-US" sz="2800" dirty="0"/>
           </a:p>
         </p:txBody>
       </p:sp>
-      <p:graphicFrame>
-        <p:nvGraphicFramePr>
-          <p:cNvPr id="3" name="Chart 0" descr=""/>
-          <p:cNvGraphicFramePr/>
-          <p:nvPr/>
-        </p:nvGraphicFramePr>
-        <p:xfrm>
-          <a:off x="365760" y="1005840"/>
-          <a:ext cx="4937760" cy="2926080"/>
-        </p:xfrm>
-        <a:graphic xmlns:a="http://schemas.openxmlformats.org/drawingml/2006/main">
-          <a:graphicData uri="http://schemas.openxmlformats.org/drawingml/2006/chart">
-            <c:chart xmlns:c="http://schemas.openxmlformats.org/drawingml/2006/chart" r:id="rId1"/>
-          </a:graphicData>
-        </a:graphic>
-      </p:graphicFrame>
-      <p:sp>
-        <p:nvSpPr>
-          <p:cNvPr id="4" name="Text 1"/>
-          <p:cNvSpPr txBox="1"/>
-          <p:nvPr/>
-        </p:nvSpPr>
-        <p:spPr>
-          <a:xfrm>
-            <a:off x="457200" y="4023360"/>
-            <a:ext cx="4846320" cy="457200"/>
-          </a:xfrm>
-          <a:prstGeom prst="rect">
-            <a:avLst/>
-          </a:prstGeom>
-          <a:noFill/>
-          <a:ln/>
-        </p:spPr>
-        <p:txBody>
-          <a:bodyPr wrap="square" lIns="0" tIns="0" rIns="0" bIns="0" rtlCol="0" anchor="t"/>
-          <a:lstStyle/>
-          <a:p>
-            <a:pPr indent="0" marL="0">
-              <a:buNone/>
-            </a:pPr>
-            <a:r>
-              <a:rPr lang="en-US" sz="1200" dirty="0">
-                <a:solidFill>
-                  <a:schemeClr val="tx1"/>
-                </a:solidFill>
-              </a:rPr>
-              <a:t>Flagged 2020-08 and 2020-12 (seasonal spending); recall stayed ≥ 94.4%.</a:t>
-            </a:r>
-            <a:endParaRPr lang="en-US" sz="1200" dirty="0"/>
-          </a:p>
-        </p:txBody>
-      </p:sp>
-      <p:sp>
-        <p:nvSpPr>
-          <p:cNvPr id="5" name="card-24"/>
+      <p:sp>
+        <p:nvSpPr>
+          <p:cNvPr id="3" name="card-24"/>
           <p:cNvSpPr/>
           <p:nvPr/>
         </p:nvSpPr>
         <p:spPr>
           <a:xfrm>
-            <a:off x="5577840" y="1051560"/>
-            <a:ext cx="3108960" cy="3383280"/>
+            <a:off x="365760" y="1051560"/>
+            <a:ext cx="1572768" cy="1417320"/>
           </a:xfrm>
           <a:prstGeom prst="roundRect">
             <a:avLst>
-              <a:gd name="adj" fmla="val 2353"/>
+              <a:gd name="adj" fmla="val 5161"/>
             </a:avLst>
           </a:prstGeom>
           <a:solidFill>
@@ -4471,14 +4509,14 @@
       </p:sp>
       <p:sp>
         <p:nvSpPr>
-          <p:cNvPr id="6" name="Text 3"/>
+          <p:cNvPr id="4" name="Text 2"/>
           <p:cNvSpPr txBox="1"/>
           <p:nvPr/>
         </p:nvSpPr>
         <p:spPr>
           <a:xfrm>
-            <a:off x="5760720" y="1188720"/>
-            <a:ext cx="2743200" cy="365760"/>
+            <a:off x="475488" y="1143000"/>
+            <a:ext cx="1371600" cy="320040"/>
           </a:xfrm>
           <a:prstGeom prst="rect">
             <a:avLst/>
@@ -4494,12 +4532,507 @@
               <a:buNone/>
             </a:pPr>
             <a:r>
+              <a:rPr lang="en-US" sz="1400" b="1" dirty="0">
+                <a:solidFill>
+                  <a:schemeClr val="tx2"/>
+                </a:solidFill>
+              </a:rPr>
+              <a:t>1 Received</a:t>
+            </a:r>
+            <a:endParaRPr lang="en-US" sz="1400" dirty="0"/>
+          </a:p>
+        </p:txBody>
+      </p:sp>
+      <p:sp>
+        <p:nvSpPr>
+          <p:cNvPr id="5" name="Text 3"/>
+          <p:cNvSpPr txBox="1"/>
+          <p:nvPr/>
+        </p:nvSpPr>
+        <p:spPr>
+          <a:xfrm>
+            <a:off x="475488" y="1481328"/>
+            <a:ext cx="1371600" cy="914400"/>
+          </a:xfrm>
+          <a:prstGeom prst="rect">
+            <a:avLst/>
+          </a:prstGeom>
+          <a:noFill/>
+          <a:ln/>
+        </p:spPr>
+        <p:txBody>
+          <a:bodyPr wrap="square" lIns="0" tIns="0" rIns="0" bIns="0" rtlCol="0" anchor="t"/>
+          <a:lstStyle/>
+          <a:p>
+            <a:pPr indent="0" marL="0">
+              <a:buNone/>
+            </a:pPr>
+            <a:r>
+              <a:rPr lang="en-US" sz="1100" dirty="0">
+                <a:solidFill>
+                  <a:schemeClr val="tx1"/>
+                </a:solidFill>
+              </a:rPr>
+              <a:t>POST /score or the dashboard's Live transaction tab</a:t>
+            </a:r>
+            <a:endParaRPr lang="en-US" sz="1100" dirty="0"/>
+          </a:p>
+        </p:txBody>
+      </p:sp>
+      <p:sp>
+        <p:nvSpPr>
+          <p:cNvPr id="6" name="card-25"/>
+          <p:cNvSpPr/>
+          <p:nvPr/>
+        </p:nvSpPr>
+        <p:spPr>
+          <a:xfrm>
+            <a:off x="2066544" y="1051560"/>
+            <a:ext cx="1572768" cy="1417320"/>
+          </a:xfrm>
+          <a:prstGeom prst="roundRect">
+            <a:avLst>
+              <a:gd name="adj" fmla="val 5161"/>
+            </a:avLst>
+          </a:prstGeom>
+          <a:solidFill>
+            <a:schemeClr val="bg2"/>
+          </a:solidFill>
+          <a:ln w="12700">
+            <a:solidFill>
+              <a:schemeClr val="bg2"/>
+            </a:solidFill>
+            <a:prstDash val="solid"/>
+          </a:ln>
+        </p:spPr>
+      </p:sp>
+      <p:sp>
+        <p:nvSpPr>
+          <p:cNvPr id="7" name="Text 5"/>
+          <p:cNvSpPr txBox="1"/>
+          <p:nvPr/>
+        </p:nvSpPr>
+        <p:spPr>
+          <a:xfrm>
+            <a:off x="2176272" y="1143000"/>
+            <a:ext cx="1371600" cy="320040"/>
+          </a:xfrm>
+          <a:prstGeom prst="rect">
+            <a:avLst/>
+          </a:prstGeom>
+          <a:noFill/>
+          <a:ln/>
+        </p:spPr>
+        <p:txBody>
+          <a:bodyPr wrap="square" lIns="0" tIns="0" rIns="0" bIns="0" rtlCol="0" anchor="t"/>
+          <a:lstStyle/>
+          <a:p>
+            <a:pPr indent="0" marL="0">
+              <a:buNone/>
+            </a:pPr>
+            <a:r>
+              <a:rPr lang="en-US" sz="1400" b="1" dirty="0">
+                <a:solidFill>
+                  <a:schemeClr val="tx2"/>
+                </a:solidFill>
+              </a:rPr>
+              <a:t>2 Features</a:t>
+            </a:r>
+            <a:endParaRPr lang="en-US" sz="1400" dirty="0"/>
+          </a:p>
+        </p:txBody>
+      </p:sp>
+      <p:sp>
+        <p:nvSpPr>
+          <p:cNvPr id="8" name="Text 6"/>
+          <p:cNvSpPr txBox="1"/>
+          <p:nvPr/>
+        </p:nvSpPr>
+        <p:spPr>
+          <a:xfrm>
+            <a:off x="2176272" y="1481328"/>
+            <a:ext cx="1371600" cy="914400"/>
+          </a:xfrm>
+          <a:prstGeom prst="rect">
+            <a:avLst/>
+          </a:prstGeom>
+          <a:noFill/>
+          <a:ln/>
+        </p:spPr>
+        <p:txBody>
+          <a:bodyPr wrap="square" lIns="0" tIns="0" rIns="0" bIns="0" rtlCol="0" anchor="t"/>
+          <a:lstStyle/>
+          <a:p>
+            <a:pPr indent="0" marL="0">
+              <a:buNone/>
+            </a:pPr>
+            <a:r>
+              <a:rPr lang="en-US" sz="1100" dirty="0">
+                <a:solidFill>
+                  <a:schemeClr val="tx1"/>
+                </a:solidFill>
+              </a:rPr>
+              <a:t>online feature store: card history, velocity 1 h / 24 h / 7 d</a:t>
+            </a:r>
+            <a:endParaRPr lang="en-US" sz="1100" dirty="0"/>
+          </a:p>
+        </p:txBody>
+      </p:sp>
+      <p:sp>
+        <p:nvSpPr>
+          <p:cNvPr id="9" name="card-26"/>
+          <p:cNvSpPr/>
+          <p:nvPr/>
+        </p:nvSpPr>
+        <p:spPr>
+          <a:xfrm>
+            <a:off x="3767328" y="1051560"/>
+            <a:ext cx="1572768" cy="1417320"/>
+          </a:xfrm>
+          <a:prstGeom prst="roundRect">
+            <a:avLst>
+              <a:gd name="adj" fmla="val 5161"/>
+            </a:avLst>
+          </a:prstGeom>
+          <a:solidFill>
+            <a:schemeClr val="bg2"/>
+          </a:solidFill>
+          <a:ln w="12700">
+            <a:solidFill>
+              <a:schemeClr val="bg2"/>
+            </a:solidFill>
+            <a:prstDash val="solid"/>
+          </a:ln>
+        </p:spPr>
+      </p:sp>
+      <p:sp>
+        <p:nvSpPr>
+          <p:cNvPr id="10" name="Text 8"/>
+          <p:cNvSpPr txBox="1"/>
+          <p:nvPr/>
+        </p:nvSpPr>
+        <p:spPr>
+          <a:xfrm>
+            <a:off x="3877056" y="1143000"/>
+            <a:ext cx="1371600" cy="320040"/>
+          </a:xfrm>
+          <a:prstGeom prst="rect">
+            <a:avLst/>
+          </a:prstGeom>
+          <a:noFill/>
+          <a:ln/>
+        </p:spPr>
+        <p:txBody>
+          <a:bodyPr wrap="square" lIns="0" tIns="0" rIns="0" bIns="0" rtlCol="0" anchor="t"/>
+          <a:lstStyle/>
+          <a:p>
+            <a:pPr indent="0" marL="0">
+              <a:buNone/>
+            </a:pPr>
+            <a:r>
+              <a:rPr lang="en-US" sz="1400" b="1" dirty="0">
+                <a:solidFill>
+                  <a:schemeClr val="tx2"/>
+                </a:solidFill>
+              </a:rPr>
+              <a:t>3 Inference</a:t>
+            </a:r>
+            <a:endParaRPr lang="en-US" sz="1400" dirty="0"/>
+          </a:p>
+        </p:txBody>
+      </p:sp>
+      <p:sp>
+        <p:nvSpPr>
+          <p:cNvPr id="11" name="Text 9"/>
+          <p:cNvSpPr txBox="1"/>
+          <p:nvPr/>
+        </p:nvSpPr>
+        <p:spPr>
+          <a:xfrm>
+            <a:off x="3877056" y="1481328"/>
+            <a:ext cx="1371600" cy="914400"/>
+          </a:xfrm>
+          <a:prstGeom prst="rect">
+            <a:avLst/>
+          </a:prstGeom>
+          <a:noFill/>
+          <a:ln/>
+        </p:spPr>
+        <p:txBody>
+          <a:bodyPr wrap="square" lIns="0" tIns="0" rIns="0" bIns="0" rtlCol="0" anchor="t"/>
+          <a:lstStyle/>
+          <a:p>
+            <a:pPr indent="0" marL="0">
+              <a:buNone/>
+            </a:pPr>
+            <a:r>
+              <a:rPr lang="en-US" sz="1100" dirty="0">
+                <a:solidFill>
+                  <a:schemeClr val="tx1"/>
+                </a:solidFill>
+              </a:rPr>
+              <a:t>score vs threshold, SHAP reasons, counterfactual amount</a:t>
+            </a:r>
+            <a:endParaRPr lang="en-US" sz="1100" dirty="0"/>
+          </a:p>
+        </p:txBody>
+      </p:sp>
+      <p:sp>
+        <p:nvSpPr>
+          <p:cNvPr id="12" name="card-27"/>
+          <p:cNvSpPr/>
+          <p:nvPr/>
+        </p:nvSpPr>
+        <p:spPr>
+          <a:xfrm>
+            <a:off x="5468112" y="1051560"/>
+            <a:ext cx="1572768" cy="1417320"/>
+          </a:xfrm>
+          <a:prstGeom prst="roundRect">
+            <a:avLst>
+              <a:gd name="adj" fmla="val 5161"/>
+            </a:avLst>
+          </a:prstGeom>
+          <a:solidFill>
+            <a:schemeClr val="bg2"/>
+          </a:solidFill>
+          <a:ln w="12700">
+            <a:solidFill>
+              <a:schemeClr val="bg2"/>
+            </a:solidFill>
+            <a:prstDash val="solid"/>
+          </a:ln>
+        </p:spPr>
+      </p:sp>
+      <p:sp>
+        <p:nvSpPr>
+          <p:cNvPr id="13" name="Text 11"/>
+          <p:cNvSpPr txBox="1"/>
+          <p:nvPr/>
+        </p:nvSpPr>
+        <p:spPr>
+          <a:xfrm>
+            <a:off x="5577840" y="1143000"/>
+            <a:ext cx="1371600" cy="320040"/>
+          </a:xfrm>
+          <a:prstGeom prst="rect">
+            <a:avLst/>
+          </a:prstGeom>
+          <a:noFill/>
+          <a:ln/>
+        </p:spPr>
+        <p:txBody>
+          <a:bodyPr wrap="square" lIns="0" tIns="0" rIns="0" bIns="0" rtlCol="0" anchor="t"/>
+          <a:lstStyle/>
+          <a:p>
+            <a:pPr indent="0" marL="0">
+              <a:buNone/>
+            </a:pPr>
+            <a:r>
+              <a:rPr lang="en-US" sz="1400" b="1" dirty="0">
+                <a:solidFill>
+                  <a:schemeClr val="tx2"/>
+                </a:solidFill>
+              </a:rPr>
+              <a:t>4 Routed</a:t>
+            </a:r>
+            <a:endParaRPr lang="en-US" sz="1400" dirty="0"/>
+          </a:p>
+        </p:txBody>
+      </p:sp>
+      <p:sp>
+        <p:nvSpPr>
+          <p:cNvPr id="14" name="Text 12"/>
+          <p:cNvSpPr txBox="1"/>
+          <p:nvPr/>
+        </p:nvSpPr>
+        <p:spPr>
+          <a:xfrm>
+            <a:off x="5577840" y="1481328"/>
+            <a:ext cx="1371600" cy="914400"/>
+          </a:xfrm>
+          <a:prstGeom prst="rect">
+            <a:avLst/>
+          </a:prstGeom>
+          <a:noFill/>
+          <a:ln/>
+        </p:spPr>
+        <p:txBody>
+          <a:bodyPr wrap="square" lIns="0" tIns="0" rIns="0" bIns="0" rtlCol="0" anchor="t"/>
+          <a:lstStyle/>
+          <a:p>
+            <a:pPr indent="0" marL="0">
+              <a:buNone/>
+            </a:pPr>
+            <a:r>
+              <a:rPr lang="en-US" sz="1100" dirty="0">
+                <a:solidFill>
+                  <a:schemeClr val="tx1"/>
+                </a:solidFill>
+              </a:rPr>
+              <a:t>alert → case opened in the review queue; else approved</a:t>
+            </a:r>
+            <a:endParaRPr lang="en-US" sz="1100" dirty="0"/>
+          </a:p>
+        </p:txBody>
+      </p:sp>
+      <p:sp>
+        <p:nvSpPr>
+          <p:cNvPr id="15" name="card-28"/>
+          <p:cNvSpPr/>
+          <p:nvPr/>
+        </p:nvSpPr>
+        <p:spPr>
+          <a:xfrm>
+            <a:off x="7168896" y="1051560"/>
+            <a:ext cx="1572768" cy="1417320"/>
+          </a:xfrm>
+          <a:prstGeom prst="roundRect">
+            <a:avLst>
+              <a:gd name="adj" fmla="val 5161"/>
+            </a:avLst>
+          </a:prstGeom>
+          <a:solidFill>
+            <a:schemeClr val="bg2"/>
+          </a:solidFill>
+          <a:ln w="12700">
+            <a:solidFill>
+              <a:schemeClr val="bg2"/>
+            </a:solidFill>
+            <a:prstDash val="solid"/>
+          </a:ln>
+        </p:spPr>
+      </p:sp>
+      <p:sp>
+        <p:nvSpPr>
+          <p:cNvPr id="16" name="Text 14"/>
+          <p:cNvSpPr txBox="1"/>
+          <p:nvPr/>
+        </p:nvSpPr>
+        <p:spPr>
+          <a:xfrm>
+            <a:off x="7278624" y="1143000"/>
+            <a:ext cx="1371600" cy="320040"/>
+          </a:xfrm>
+          <a:prstGeom prst="rect">
+            <a:avLst/>
+          </a:prstGeom>
+          <a:noFill/>
+          <a:ln/>
+        </p:spPr>
+        <p:txBody>
+          <a:bodyPr wrap="square" lIns="0" tIns="0" rIns="0" bIns="0" rtlCol="0" anchor="t"/>
+          <a:lstStyle/>
+          <a:p>
+            <a:pPr indent="0" marL="0">
+              <a:buNone/>
+            </a:pPr>
+            <a:r>
+              <a:rPr lang="en-US" sz="1400" b="1" dirty="0">
+                <a:solidFill>
+                  <a:schemeClr val="accent1"/>
+                </a:solidFill>
+              </a:rPr>
+              <a:t>5 Decision</a:t>
+            </a:r>
+            <a:endParaRPr lang="en-US" sz="1400" dirty="0"/>
+          </a:p>
+        </p:txBody>
+      </p:sp>
+      <p:sp>
+        <p:nvSpPr>
+          <p:cNvPr id="17" name="Text 15"/>
+          <p:cNvSpPr txBox="1"/>
+          <p:nvPr/>
+        </p:nvSpPr>
+        <p:spPr>
+          <a:xfrm>
+            <a:off x="7278624" y="1481328"/>
+            <a:ext cx="1371600" cy="914400"/>
+          </a:xfrm>
+          <a:prstGeom prst="rect">
+            <a:avLst/>
+          </a:prstGeom>
+          <a:noFill/>
+          <a:ln/>
+        </p:spPr>
+        <p:txBody>
+          <a:bodyPr wrap="square" lIns="0" tIns="0" rIns="0" bIns="0" rtlCol="0" anchor="t"/>
+          <a:lstStyle/>
+          <a:p>
+            <a:pPr indent="0" marL="0">
+              <a:buNone/>
+            </a:pPr>
+            <a:r>
+              <a:rPr lang="en-US" sz="1100" dirty="0">
+                <a:solidFill>
+                  <a:schemeClr val="tx1"/>
+                </a:solidFill>
+              </a:rPr>
+              <a:t>analyst: fraud / legitimate + note; audit log</a:t>
+            </a:r>
+            <a:endParaRPr lang="en-US" sz="1100" dirty="0"/>
+          </a:p>
+        </p:txBody>
+      </p:sp>
+      <p:sp>
+        <p:nvSpPr>
+          <p:cNvPr id="18" name="card-29"/>
+          <p:cNvSpPr/>
+          <p:nvPr/>
+        </p:nvSpPr>
+        <p:spPr>
+          <a:xfrm>
+            <a:off x="365760" y="2697480"/>
+            <a:ext cx="8412480" cy="1783080"/>
+          </a:xfrm>
+          <a:prstGeom prst="roundRect">
+            <a:avLst>
+              <a:gd name="adj" fmla="val 4103"/>
+            </a:avLst>
+          </a:prstGeom>
+          <a:solidFill>
+            <a:schemeClr val="bg2"/>
+          </a:solidFill>
+          <a:ln w="12700">
+            <a:solidFill>
+              <a:schemeClr val="bg2"/>
+            </a:solidFill>
+            <a:prstDash val="solid"/>
+          </a:ln>
+        </p:spPr>
+      </p:sp>
+      <p:sp>
+        <p:nvSpPr>
+          <p:cNvPr id="19" name="Text 17"/>
+          <p:cNvSpPr txBox="1"/>
+          <p:nvPr/>
+        </p:nvSpPr>
+        <p:spPr>
+          <a:xfrm>
+            <a:off x="548640" y="2788920"/>
+            <a:ext cx="8046720" cy="320040"/>
+          </a:xfrm>
+          <a:prstGeom prst="rect">
+            <a:avLst/>
+          </a:prstGeom>
+          <a:noFill/>
+          <a:ln/>
+        </p:spPr>
+        <p:txBody>
+          <a:bodyPr wrap="square" lIns="0" tIns="0" rIns="0" bIns="0" rtlCol="0" anchor="t"/>
+          <a:lstStyle/>
+          <a:p>
+            <a:pPr indent="0" marL="0">
+              <a:buNone/>
+            </a:pPr>
+            <a:r>
               <a:rPr lang="en-US" sz="1500" b="1" dirty="0">
                 <a:solidFill>
-                  <a:schemeClr val="tx2"/>
-                </a:solidFill>
-              </a:rPr>
-              <a:t>Improvement loop</a:t>
+                  <a:schemeClr val="accent3"/>
+                </a:solidFill>
+              </a:rPr>
+              <a:t>How decisions inform monitoring</a:t>
             </a:r>
             <a:endParaRPr lang="en-US" sz="1500" dirty="0"/>
           </a:p>
@@ -4507,14 +5040,14 @@
       </p:sp>
       <p:sp>
         <p:nvSpPr>
-          <p:cNvPr id="7" name="Text 4"/>
+          <p:cNvPr id="20" name="Text 18"/>
           <p:cNvSpPr txBox="1"/>
           <p:nvPr/>
         </p:nvSpPr>
         <p:spPr>
           <a:xfrm>
-            <a:off x="5760720" y="1600200"/>
-            <a:ext cx="2788920" cy="2743200"/>
+            <a:off x="548640" y="3154680"/>
+            <a:ext cx="8046720" cy="1280160"/>
           </a:xfrm>
           <a:prstGeom prst="rect">
             <a:avLst/>
@@ -4534,14 +5067,14 @@
               <a:buChar char="•"/>
             </a:pPr>
             <a:r>
-              <a:rPr lang="en-US" sz="1200" dirty="0">
+              <a:rPr lang="en-US" sz="1250" dirty="0">
                 <a:solidFill>
                   <a:schemeClr val="tx1"/>
                 </a:solidFill>
               </a:rPr>
-              <a:t>Evidently drift + PSI and performance each month</a:t>
-            </a:r>
-            <a:endParaRPr lang="en-US" sz="1200" dirty="0"/>
+              <a:t>Live precision (confirmed ÷ reviewed alerts) with a 95% interval vs the 40% floor → threshold/model review, Prometheus alert</a:t>
+            </a:r>
+            <a:endParaRPr lang="en-US" sz="1250" dirty="0"/>
           </a:p>
           <a:p>
             <a:pPr marL="177800" indent="-177800">
@@ -4552,14 +5085,14 @@
               <a:buChar char="•"/>
             </a:pPr>
             <a:r>
-              <a:rPr lang="en-US" sz="1200" dirty="0">
+              <a:rPr lang="en-US" sz="1250" dirty="0">
                 <a:solidFill>
                   <a:schemeClr val="tx1"/>
                 </a:solidFill>
               </a:rPr>
-              <a:t>Prometheus alert rules; Grafana operations and business dashboards</a:t>
-            </a:r>
-            <a:endParaRPr lang="en-US" sz="1200" dirty="0"/>
+              <a:t>Fraud reported on approved transactions = live misses; backlog and time to decision = workload</a:t>
+            </a:r>
+            <a:endParaRPr lang="en-US" sz="1250" dirty="0"/>
           </a:p>
           <a:p>
             <a:pPr marL="177800" indent="-177800">
@@ -4570,32 +5103,14 @@
               <a:buChar char="•"/>
             </a:pPr>
             <a:r>
-              <a:rPr lang="en-US" sz="1200" dirty="0">
+              <a:rPr lang="en-US" sz="1250" dirty="0">
                 <a:solidFill>
                   <a:schemeClr val="tx1"/>
                 </a:solidFill>
               </a:rPr>
-              <a:t>Analyst feedback via /feedback</a:t>
-            </a:r>
-            <a:endParaRPr lang="en-US" sz="1200" dirty="0"/>
-          </a:p>
-          <a:p>
-            <a:pPr marL="177800" indent="-177800">
-              <a:spcAft>
-                <a:spcPts val="600"/>
-              </a:spcAft>
-              <a:buSzPct val="100000"/>
-              <a:buChar char="•"/>
-            </a:pPr>
-            <a:r>
-              <a:rPr lang="en-US" sz="1200" dirty="0">
-                <a:solidFill>
-                  <a:schemeClr val="tx1"/>
-                </a:solidFill>
-              </a:rPr>
-              <a:t>Challenger retrained on train + val: PR-AUC 0.9741 vs 0.9698 → promote via MLflow alias</a:t>
-            </a:r>
-            <a:endParaRPr lang="en-US" sz="1200" dirty="0"/>
+              <a:t>Every decided case keeps its exact model inputs → labelled examples for the next champion/challenger</a:t>
+            </a:r>
+            <a:endParaRPr lang="en-US" sz="1250" dirty="0"/>
           </a:p>
         </p:txBody>
       </p:sp>
@@ -4704,26 +5219,78 @@
                 <a:ea typeface="Cambria" pitchFamily="34" charset="-122"/>
                 <a:cs typeface="Cambria" pitchFamily="34" charset="-120"/>
               </a:rPr>
-              <a:t>Managed and verified like a product</a:t>
+              <a:t>Monitoring closes the loop</a:t>
             </a:r>
             <a:endParaRPr lang="en-US" sz="2800" dirty="0"/>
           </a:p>
         </p:txBody>
       </p:sp>
-      <p:sp>
-        <p:nvSpPr>
-          <p:cNvPr id="3" name="card-25"/>
+      <p:graphicFrame>
+        <p:nvGraphicFramePr>
+          <p:cNvPr id="3" name="Chart 0" descr=""/>
+          <p:cNvGraphicFramePr/>
+          <p:nvPr/>
+        </p:nvGraphicFramePr>
+        <p:xfrm>
+          <a:off x="365760" y="1005840"/>
+          <a:ext cx="4937760" cy="2926080"/>
+        </p:xfrm>
+        <a:graphic xmlns:a="http://schemas.openxmlformats.org/drawingml/2006/main">
+          <a:graphicData uri="http://schemas.openxmlformats.org/drawingml/2006/chart">
+            <c:chart xmlns:c="http://schemas.openxmlformats.org/drawingml/2006/chart" r:id="rId1"/>
+          </a:graphicData>
+        </a:graphic>
+      </p:graphicFrame>
+      <p:sp>
+        <p:nvSpPr>
+          <p:cNvPr id="4" name="Text 1"/>
+          <p:cNvSpPr txBox="1"/>
+          <p:nvPr/>
+        </p:nvSpPr>
+        <p:spPr>
+          <a:xfrm>
+            <a:off x="457200" y="4023360"/>
+            <a:ext cx="4846320" cy="457200"/>
+          </a:xfrm>
+          <a:prstGeom prst="rect">
+            <a:avLst/>
+          </a:prstGeom>
+          <a:noFill/>
+          <a:ln/>
+        </p:spPr>
+        <p:txBody>
+          <a:bodyPr wrap="square" lIns="0" tIns="0" rIns="0" bIns="0" rtlCol="0" anchor="t"/>
+          <a:lstStyle/>
+          <a:p>
+            <a:pPr indent="0" marL="0">
+              <a:buNone/>
+            </a:pPr>
+            <a:r>
+              <a:rPr lang="en-US" sz="1200" dirty="0">
+                <a:solidFill>
+                  <a:schemeClr val="tx1"/>
+                </a:solidFill>
+              </a:rPr>
+              <a:t>Flagged 2020-08 and 2020-12 (seasonal spending); recall stayed ≥ 94.4%.</a:t>
+            </a:r>
+            <a:endParaRPr lang="en-US" sz="1200" dirty="0"/>
+          </a:p>
+        </p:txBody>
+      </p:sp>
+      <p:sp>
+        <p:nvSpPr>
+          <p:cNvPr id="5" name="card-30"/>
           <p:cNvSpPr/>
           <p:nvPr/>
         </p:nvSpPr>
         <p:spPr>
           <a:xfrm>
-            <a:off x="457200" y="1097280"/>
-            <a:ext cx="2606040" cy="3200400"/>
+            <a:off x="5577840" y="1051560"/>
+            <a:ext cx="3108960" cy="3383280"/>
           </a:xfrm>
           <a:prstGeom prst="roundRect">
             <a:avLst>
-              <a:gd name="adj" fmla="val 2807"/>
+              <a:gd name="adj" fmla="val 2353"/>
             </a:avLst>
           </a:prstGeom>
           <a:solidFill>
@@ -4739,14 +5306,14 @@
       </p:sp>
       <p:sp>
         <p:nvSpPr>
-          <p:cNvPr id="4" name="Text 2"/>
+          <p:cNvPr id="6" name="Text 3"/>
           <p:cNvSpPr txBox="1"/>
           <p:nvPr/>
         </p:nvSpPr>
         <p:spPr>
           <a:xfrm>
-            <a:off x="640080" y="1234440"/>
-            <a:ext cx="2240280" cy="365760"/>
+            <a:off x="5760720" y="1188720"/>
+            <a:ext cx="2743200" cy="365760"/>
           </a:xfrm>
           <a:prstGeom prst="rect">
             <a:avLst/>
@@ -4762,27 +5329,27 @@
               <a:buNone/>
             </a:pPr>
             <a:r>
-              <a:rPr lang="en-US" sz="1600" b="1" dirty="0">
-                <a:solidFill>
-                  <a:schemeClr val="accent3"/>
-                </a:solidFill>
-              </a:rPr>
-              <a:t>GitHub Project</a:t>
-            </a:r>
-            <a:endParaRPr lang="en-US" sz="1600" dirty="0"/>
-          </a:p>
-        </p:txBody>
-      </p:sp>
-      <p:sp>
-        <p:nvSpPr>
-          <p:cNvPr id="5" name="Text 3"/>
+              <a:rPr lang="en-US" sz="1500" b="1" dirty="0">
+                <a:solidFill>
+                  <a:schemeClr val="tx2"/>
+                </a:solidFill>
+              </a:rPr>
+              <a:t>Improvement loop</a:t>
+            </a:r>
+            <a:endParaRPr lang="en-US" sz="1500" dirty="0"/>
+          </a:p>
+        </p:txBody>
+      </p:sp>
+      <p:sp>
+        <p:nvSpPr>
+          <p:cNvPr id="7" name="Text 4"/>
           <p:cNvSpPr txBox="1"/>
           <p:nvPr/>
         </p:nvSpPr>
         <p:spPr>
           <a:xfrm>
-            <a:off x="640080" y="1691640"/>
-            <a:ext cx="2286000" cy="2468880"/>
+            <a:off x="5760720" y="1600200"/>
+            <a:ext cx="2788920" cy="2743200"/>
           </a:xfrm>
           <a:prstGeom prst="rect">
             <a:avLst/>
@@ -4802,14 +5369,14 @@
               <a:buChar char="•"/>
             </a:pPr>
             <a:r>
-              <a:rPr lang="en-US" sz="1300" dirty="0">
+              <a:rPr lang="en-US" sz="1200" dirty="0">
                 <a:solidFill>
                   <a:schemeClr val="tx1"/>
                 </a:solidFill>
               </a:rPr>
-              <a:t>Board generated from project_plan.yaml</a:t>
-            </a:r>
-            <a:endParaRPr lang="en-US" sz="1300" dirty="0"/>
+              <a:t>Evidently drift + PSI and performance each month</a:t>
+            </a:r>
+            <a:endParaRPr lang="en-US" sz="1200" dirty="0"/>
           </a:p>
           <a:p>
             <a:pPr marL="177800" indent="-177800">
@@ -4820,14 +5387,14 @@
               <a:buChar char="•"/>
             </a:pPr>
             <a:r>
-              <a:rPr lang="en-US" sz="1300" dirty="0">
+              <a:rPr lang="en-US" sz="1200" dirty="0">
                 <a:solidFill>
                   <a:schemeClr val="tx1"/>
                 </a:solidFill>
               </a:rPr>
-              <a:t>4 milestones, one issue per task with acceptance checklist</a:t>
-            </a:r>
-            <a:endParaRPr lang="en-US" sz="1300" dirty="0"/>
+              <a:t>Prometheus alert rules; Grafana operations and business dashboards</a:t>
+            </a:r>
+            <a:endParaRPr lang="en-US" sz="1200" dirty="0"/>
           </a:p>
           <a:p>
             <a:pPr marL="177800" indent="-177800">
@@ -4838,100 +5405,15 @@
               <a:buChar char="•"/>
             </a:pPr>
             <a:r>
-              <a:rPr lang="en-US" sz="1300" dirty="0">
+              <a:rPr lang="en-US" sz="1200" dirty="0">
                 <a:solidFill>
                   <a:schemeClr val="tx1"/>
                 </a:solidFill>
               </a:rPr>
-              <a:t>Lifecycle-stage field tracks progress stage by stage</a:t>
-            </a:r>
-            <a:endParaRPr lang="en-US" sz="1300" dirty="0"/>
-          </a:p>
-        </p:txBody>
-      </p:sp>
-      <p:sp>
-        <p:nvSpPr>
-          <p:cNvPr id="6" name="card-26"/>
-          <p:cNvSpPr/>
-          <p:nvPr/>
-        </p:nvSpPr>
-        <p:spPr>
-          <a:xfrm>
-            <a:off x="3246120" y="1097280"/>
-            <a:ext cx="2606040" cy="3200400"/>
-          </a:xfrm>
-          <a:prstGeom prst="roundRect">
-            <a:avLst>
-              <a:gd name="adj" fmla="val 2807"/>
-            </a:avLst>
-          </a:prstGeom>
-          <a:solidFill>
-            <a:schemeClr val="bg2"/>
-          </a:solidFill>
-          <a:ln w="12700">
-            <a:solidFill>
-              <a:schemeClr val="bg2"/>
-            </a:solidFill>
-            <a:prstDash val="solid"/>
-          </a:ln>
-        </p:spPr>
-      </p:sp>
-      <p:sp>
-        <p:nvSpPr>
-          <p:cNvPr id="7" name="Text 5"/>
-          <p:cNvSpPr txBox="1"/>
-          <p:nvPr/>
-        </p:nvSpPr>
-        <p:spPr>
-          <a:xfrm>
-            <a:off x="3429000" y="1234440"/>
-            <a:ext cx="2240280" cy="365760"/>
-          </a:xfrm>
-          <a:prstGeom prst="rect">
-            <a:avLst/>
-          </a:prstGeom>
-          <a:noFill/>
-          <a:ln/>
-        </p:spPr>
-        <p:txBody>
-          <a:bodyPr wrap="square" lIns="0" tIns="0" rIns="0" bIns="0" rtlCol="0" anchor="t"/>
-          <a:lstStyle/>
-          <a:p>
-            <a:pPr indent="0" marL="0">
-              <a:buNone/>
-            </a:pPr>
-            <a:r>
-              <a:rPr lang="en-US" sz="1600" b="1" dirty="0">
-                <a:solidFill>
-                  <a:schemeClr val="accent2"/>
-                </a:solidFill>
-              </a:rPr>
-              <a:t>CI/CD</a:t>
-            </a:r>
-            <a:endParaRPr lang="en-US" sz="1600" dirty="0"/>
-          </a:p>
-        </p:txBody>
-      </p:sp>
-      <p:sp>
-        <p:nvSpPr>
-          <p:cNvPr id="8" name="Text 6"/>
-          <p:cNvSpPr txBox="1"/>
-          <p:nvPr/>
-        </p:nvSpPr>
-        <p:spPr>
-          <a:xfrm>
-            <a:off x="3429000" y="1691640"/>
-            <a:ext cx="2286000" cy="2468880"/>
-          </a:xfrm>
-          <a:prstGeom prst="rect">
-            <a:avLst/>
-          </a:prstGeom>
-          <a:noFill/>
-          <a:ln/>
-        </p:spPr>
-        <p:txBody>
-          <a:bodyPr wrap="square" lIns="0" tIns="0" rIns="0" bIns="0" rtlCol="0" anchor="t"/>
-          <a:lstStyle/>
+              <a:t>Analyst feedback via /feedback</a:t>
+            </a:r>
+            <a:endParaRPr lang="en-US" sz="1200" dirty="0"/>
+          </a:p>
           <a:p>
             <a:pPr marL="177800" indent="-177800">
               <a:spcAft>
@@ -4941,189 +5423,14 @@
               <a:buChar char="•"/>
             </a:pPr>
             <a:r>
-              <a:rPr lang="en-US" sz="1300" dirty="0">
+              <a:rPr lang="en-US" sz="1200" dirty="0">
                 <a:solidFill>
                   <a:schemeClr val="tx1"/>
                 </a:solidFill>
               </a:rPr>
-              <a:t>ci: full lifecycle on sample data + dashboard render</a:t>
-            </a:r>
-            <a:endParaRPr lang="en-US" sz="1300" dirty="0"/>
-          </a:p>
-          <a:p>
-            <a:pPr marL="177800" indent="-177800">
-              <a:spcAft>
-                <a:spcPts val="600"/>
-              </a:spcAft>
-              <a:buSzPct val="100000"/>
-              <a:buChar char="•"/>
-            </a:pPr>
-            <a:r>
-              <a:rPr lang="en-US" sz="1300" dirty="0">
-                <a:solidFill>
-                  <a:schemeClr val="tx1"/>
-                </a:solidFill>
-              </a:rPr>
-              <a:t>platform: Docker stack end to end, 14/14 smoke checks pass</a:t>
-            </a:r>
-            <a:endParaRPr lang="en-US" sz="1300" dirty="0"/>
-          </a:p>
-          <a:p>
-            <a:pPr marL="177800" indent="-177800">
-              <a:spcAft>
-                <a:spcPts val="600"/>
-              </a:spcAft>
-              <a:buSzPct val="100000"/>
-              <a:buChar char="•"/>
-            </a:pPr>
-            <a:r>
-              <a:rPr lang="en-US" sz="1300" dirty="0">
-                <a:solidFill>
-                  <a:schemeClr val="tx1"/>
-                </a:solidFill>
-              </a:rPr>
-              <a:t>deploy: build, test, publish the image</a:t>
-            </a:r>
-            <a:endParaRPr lang="en-US" sz="1300" dirty="0"/>
-          </a:p>
-        </p:txBody>
-      </p:sp>
-      <p:sp>
-        <p:nvSpPr>
-          <p:cNvPr id="9" name="card-27"/>
-          <p:cNvSpPr/>
-          <p:nvPr/>
-        </p:nvSpPr>
-        <p:spPr>
-          <a:xfrm>
-            <a:off x="6035040" y="1097280"/>
-            <a:ext cx="2606040" cy="3200400"/>
-          </a:xfrm>
-          <a:prstGeom prst="roundRect">
-            <a:avLst>
-              <a:gd name="adj" fmla="val 2807"/>
-            </a:avLst>
-          </a:prstGeom>
-          <a:solidFill>
-            <a:schemeClr val="bg2"/>
-          </a:solidFill>
-          <a:ln w="12700">
-            <a:solidFill>
-              <a:schemeClr val="bg2"/>
-            </a:solidFill>
-            <a:prstDash val="solid"/>
-          </a:ln>
-        </p:spPr>
-      </p:sp>
-      <p:sp>
-        <p:nvSpPr>
-          <p:cNvPr id="10" name="Text 8"/>
-          <p:cNvSpPr txBox="1"/>
-          <p:nvPr/>
-        </p:nvSpPr>
-        <p:spPr>
-          <a:xfrm>
-            <a:off x="6217920" y="1234440"/>
-            <a:ext cx="2240280" cy="365760"/>
-          </a:xfrm>
-          <a:prstGeom prst="rect">
-            <a:avLst/>
-          </a:prstGeom>
-          <a:noFill/>
-          <a:ln/>
-        </p:spPr>
-        <p:txBody>
-          <a:bodyPr wrap="square" lIns="0" tIns="0" rIns="0" bIns="0" rtlCol="0" anchor="t"/>
-          <a:lstStyle/>
-          <a:p>
-            <a:pPr indent="0" marL="0">
-              <a:buNone/>
-            </a:pPr>
-            <a:r>
-              <a:rPr lang="en-US" sz="1600" b="1" dirty="0">
-                <a:solidFill>
-                  <a:schemeClr val="accent1"/>
-                </a:solidFill>
-              </a:rPr>
-              <a:t>Quality</a:t>
-            </a:r>
-            <a:endParaRPr lang="en-US" sz="1600" dirty="0"/>
-          </a:p>
-        </p:txBody>
-      </p:sp>
-      <p:sp>
-        <p:nvSpPr>
-          <p:cNvPr id="11" name="Text 9"/>
-          <p:cNvSpPr txBox="1"/>
-          <p:nvPr/>
-        </p:nvSpPr>
-        <p:spPr>
-          <a:xfrm>
-            <a:off x="6217920" y="1691640"/>
-            <a:ext cx="2286000" cy="2468880"/>
-          </a:xfrm>
-          <a:prstGeom prst="rect">
-            <a:avLst/>
-          </a:prstGeom>
-          <a:noFill/>
-          <a:ln/>
-        </p:spPr>
-        <p:txBody>
-          <a:bodyPr wrap="square" lIns="0" tIns="0" rIns="0" bIns="0" rtlCol="0" anchor="t"/>
-          <a:lstStyle/>
-          <a:p>
-            <a:pPr marL="177800" indent="-177800">
-              <a:spcAft>
-                <a:spcPts val="600"/>
-              </a:spcAft>
-              <a:buSzPct val="100000"/>
-              <a:buChar char="•"/>
-            </a:pPr>
-            <a:r>
-              <a:rPr lang="en-US" sz="1300" dirty="0">
-                <a:solidFill>
-                  <a:schemeClr val="tx1"/>
-                </a:solidFill>
-              </a:rPr>
-              <a:t>56/56 verification checks pass</a:t>
-            </a:r>
-            <a:endParaRPr lang="en-US" sz="1300" dirty="0"/>
-          </a:p>
-          <a:p>
-            <a:pPr marL="177800" indent="-177800">
-              <a:spcAft>
-                <a:spcPts val="600"/>
-              </a:spcAft>
-              <a:buSzPct val="100000"/>
-              <a:buChar char="•"/>
-            </a:pPr>
-            <a:r>
-              <a:rPr lang="en-US" sz="1300" dirty="0">
-                <a:solidFill>
-                  <a:schemeClr val="tx1"/>
-                </a:solidFill>
-              </a:rPr>
-              <a:t>Train/serve parity test (caught a real bug)</a:t>
-            </a:r>
-            <a:endParaRPr lang="en-US" sz="1300" dirty="0"/>
-          </a:p>
-          <a:p>
-            <a:pPr marL="177800" indent="-177800">
-              <a:spcAft>
-                <a:spcPts val="600"/>
-              </a:spcAft>
-              <a:buSzPct val="100000"/>
-              <a:buChar char="•"/>
-            </a:pPr>
-            <a:r>
-              <a:rPr lang="en-US" sz="1300" dirty="0">
-                <a:solidFill>
-                  <a:schemeClr val="tx1"/>
-                </a:solidFill>
-              </a:rPr>
-              <a:t>Pinned versions, one-command rebuild</a:t>
-            </a:r>
-            <a:endParaRPr lang="en-US" sz="1300" dirty="0"/>
+              <a:t>Challenger retrained on train + val: PR-AUC 0.9741 vs 0.9698 → promote via MLflow alias</a:t>
+            </a:r>
+            <a:endParaRPr lang="en-US" sz="1200" dirty="0"/>
           </a:p>
         </p:txBody>
       </p:sp>
@@ -5207,6 +5514,534 @@
         </p:nvSpPr>
         <p:spPr>
           <a:xfrm>
+            <a:off x="457200" y="256032"/>
+            <a:ext cx="8229600" cy="640080"/>
+          </a:xfrm>
+          <a:prstGeom prst="rect">
+            <a:avLst/>
+          </a:prstGeom>
+          <a:noFill/>
+          <a:ln/>
+        </p:spPr>
+        <p:txBody>
+          <a:bodyPr wrap="square" rtlCol="0" anchor="ctr"/>
+          <a:lstStyle/>
+          <a:p>
+            <a:pPr algn="l" indent="0" marL="0">
+              <a:buNone/>
+            </a:pPr>
+            <a:r>
+              <a:rPr lang="en-US" sz="2800" b="1" dirty="0">
+                <a:solidFill>
+                  <a:schemeClr val="tx2"/>
+                </a:solidFill>
+                <a:latin typeface="Cambria" pitchFamily="34" charset="0"/>
+                <a:ea typeface="Cambria" pitchFamily="34" charset="-122"/>
+                <a:cs typeface="Cambria" pitchFamily="34" charset="-120"/>
+              </a:rPr>
+              <a:t>Managed and verified like a product</a:t>
+            </a:r>
+            <a:endParaRPr lang="en-US" sz="2800" dirty="0"/>
+          </a:p>
+        </p:txBody>
+      </p:sp>
+      <p:sp>
+        <p:nvSpPr>
+          <p:cNvPr id="3" name="card-31"/>
+          <p:cNvSpPr/>
+          <p:nvPr/>
+        </p:nvSpPr>
+        <p:spPr>
+          <a:xfrm>
+            <a:off x="457200" y="1097280"/>
+            <a:ext cx="2606040" cy="3200400"/>
+          </a:xfrm>
+          <a:prstGeom prst="roundRect">
+            <a:avLst>
+              <a:gd name="adj" fmla="val 2807"/>
+            </a:avLst>
+          </a:prstGeom>
+          <a:solidFill>
+            <a:schemeClr val="bg2"/>
+          </a:solidFill>
+          <a:ln w="12700">
+            <a:solidFill>
+              <a:schemeClr val="bg2"/>
+            </a:solidFill>
+            <a:prstDash val="solid"/>
+          </a:ln>
+        </p:spPr>
+      </p:sp>
+      <p:sp>
+        <p:nvSpPr>
+          <p:cNvPr id="4" name="Text 2"/>
+          <p:cNvSpPr txBox="1"/>
+          <p:nvPr/>
+        </p:nvSpPr>
+        <p:spPr>
+          <a:xfrm>
+            <a:off x="640080" y="1234440"/>
+            <a:ext cx="2240280" cy="365760"/>
+          </a:xfrm>
+          <a:prstGeom prst="rect">
+            <a:avLst/>
+          </a:prstGeom>
+          <a:noFill/>
+          <a:ln/>
+        </p:spPr>
+        <p:txBody>
+          <a:bodyPr wrap="square" lIns="0" tIns="0" rIns="0" bIns="0" rtlCol="0" anchor="t"/>
+          <a:lstStyle/>
+          <a:p>
+            <a:pPr indent="0" marL="0">
+              <a:buNone/>
+            </a:pPr>
+            <a:r>
+              <a:rPr lang="en-US" sz="1600" b="1" dirty="0">
+                <a:solidFill>
+                  <a:schemeClr val="accent3"/>
+                </a:solidFill>
+              </a:rPr>
+              <a:t>GitHub Project</a:t>
+            </a:r>
+            <a:endParaRPr lang="en-US" sz="1600" dirty="0"/>
+          </a:p>
+        </p:txBody>
+      </p:sp>
+      <p:sp>
+        <p:nvSpPr>
+          <p:cNvPr id="5" name="Text 3"/>
+          <p:cNvSpPr txBox="1"/>
+          <p:nvPr/>
+        </p:nvSpPr>
+        <p:spPr>
+          <a:xfrm>
+            <a:off x="640080" y="1691640"/>
+            <a:ext cx="2286000" cy="2468880"/>
+          </a:xfrm>
+          <a:prstGeom prst="rect">
+            <a:avLst/>
+          </a:prstGeom>
+          <a:noFill/>
+          <a:ln/>
+        </p:spPr>
+        <p:txBody>
+          <a:bodyPr wrap="square" lIns="0" tIns="0" rIns="0" bIns="0" rtlCol="0" anchor="t"/>
+          <a:lstStyle/>
+          <a:p>
+            <a:pPr marL="177800" indent="-177800">
+              <a:spcAft>
+                <a:spcPts val="600"/>
+              </a:spcAft>
+              <a:buSzPct val="100000"/>
+              <a:buChar char="•"/>
+            </a:pPr>
+            <a:r>
+              <a:rPr lang="en-US" sz="1300" dirty="0">
+                <a:solidFill>
+                  <a:schemeClr val="tx1"/>
+                </a:solidFill>
+              </a:rPr>
+              <a:t>Board generated from project_plan.yaml</a:t>
+            </a:r>
+            <a:endParaRPr lang="en-US" sz="1300" dirty="0"/>
+          </a:p>
+          <a:p>
+            <a:pPr marL="177800" indent="-177800">
+              <a:spcAft>
+                <a:spcPts val="600"/>
+              </a:spcAft>
+              <a:buSzPct val="100000"/>
+              <a:buChar char="•"/>
+            </a:pPr>
+            <a:r>
+              <a:rPr lang="en-US" sz="1300" dirty="0">
+                <a:solidFill>
+                  <a:schemeClr val="tx1"/>
+                </a:solidFill>
+              </a:rPr>
+              <a:t>4 milestones, one issue per task with acceptance checklist</a:t>
+            </a:r>
+            <a:endParaRPr lang="en-US" sz="1300" dirty="0"/>
+          </a:p>
+          <a:p>
+            <a:pPr marL="177800" indent="-177800">
+              <a:spcAft>
+                <a:spcPts val="600"/>
+              </a:spcAft>
+              <a:buSzPct val="100000"/>
+              <a:buChar char="•"/>
+            </a:pPr>
+            <a:r>
+              <a:rPr lang="en-US" sz="1300" dirty="0">
+                <a:solidFill>
+                  <a:schemeClr val="tx1"/>
+                </a:solidFill>
+              </a:rPr>
+              <a:t>Lifecycle-stage field tracks progress stage by stage</a:t>
+            </a:r>
+            <a:endParaRPr lang="en-US" sz="1300" dirty="0"/>
+          </a:p>
+        </p:txBody>
+      </p:sp>
+      <p:sp>
+        <p:nvSpPr>
+          <p:cNvPr id="6" name="card-32"/>
+          <p:cNvSpPr/>
+          <p:nvPr/>
+        </p:nvSpPr>
+        <p:spPr>
+          <a:xfrm>
+            <a:off x="3246120" y="1097280"/>
+            <a:ext cx="2606040" cy="3200400"/>
+          </a:xfrm>
+          <a:prstGeom prst="roundRect">
+            <a:avLst>
+              <a:gd name="adj" fmla="val 2807"/>
+            </a:avLst>
+          </a:prstGeom>
+          <a:solidFill>
+            <a:schemeClr val="bg2"/>
+          </a:solidFill>
+          <a:ln w="12700">
+            <a:solidFill>
+              <a:schemeClr val="bg2"/>
+            </a:solidFill>
+            <a:prstDash val="solid"/>
+          </a:ln>
+        </p:spPr>
+      </p:sp>
+      <p:sp>
+        <p:nvSpPr>
+          <p:cNvPr id="7" name="Text 5"/>
+          <p:cNvSpPr txBox="1"/>
+          <p:nvPr/>
+        </p:nvSpPr>
+        <p:spPr>
+          <a:xfrm>
+            <a:off x="3429000" y="1234440"/>
+            <a:ext cx="2240280" cy="365760"/>
+          </a:xfrm>
+          <a:prstGeom prst="rect">
+            <a:avLst/>
+          </a:prstGeom>
+          <a:noFill/>
+          <a:ln/>
+        </p:spPr>
+        <p:txBody>
+          <a:bodyPr wrap="square" lIns="0" tIns="0" rIns="0" bIns="0" rtlCol="0" anchor="t"/>
+          <a:lstStyle/>
+          <a:p>
+            <a:pPr indent="0" marL="0">
+              <a:buNone/>
+            </a:pPr>
+            <a:r>
+              <a:rPr lang="en-US" sz="1600" b="1" dirty="0">
+                <a:solidFill>
+                  <a:schemeClr val="accent2"/>
+                </a:solidFill>
+              </a:rPr>
+              <a:t>CI/CD</a:t>
+            </a:r>
+            <a:endParaRPr lang="en-US" sz="1600" dirty="0"/>
+          </a:p>
+        </p:txBody>
+      </p:sp>
+      <p:sp>
+        <p:nvSpPr>
+          <p:cNvPr id="8" name="Text 6"/>
+          <p:cNvSpPr txBox="1"/>
+          <p:nvPr/>
+        </p:nvSpPr>
+        <p:spPr>
+          <a:xfrm>
+            <a:off x="3429000" y="1691640"/>
+            <a:ext cx="2286000" cy="2468880"/>
+          </a:xfrm>
+          <a:prstGeom prst="rect">
+            <a:avLst/>
+          </a:prstGeom>
+          <a:noFill/>
+          <a:ln/>
+        </p:spPr>
+        <p:txBody>
+          <a:bodyPr wrap="square" lIns="0" tIns="0" rIns="0" bIns="0" rtlCol="0" anchor="t"/>
+          <a:lstStyle/>
+          <a:p>
+            <a:pPr marL="177800" indent="-177800">
+              <a:spcAft>
+                <a:spcPts val="600"/>
+              </a:spcAft>
+              <a:buSzPct val="100000"/>
+              <a:buChar char="•"/>
+            </a:pPr>
+            <a:r>
+              <a:rPr lang="en-US" sz="1300" dirty="0">
+                <a:solidFill>
+                  <a:schemeClr val="tx1"/>
+                </a:solidFill>
+              </a:rPr>
+              <a:t>ci: full lifecycle on sample data + dashboard render</a:t>
+            </a:r>
+            <a:endParaRPr lang="en-US" sz="1300" dirty="0"/>
+          </a:p>
+          <a:p>
+            <a:pPr marL="177800" indent="-177800">
+              <a:spcAft>
+                <a:spcPts val="600"/>
+              </a:spcAft>
+              <a:buSzPct val="100000"/>
+              <a:buChar char="•"/>
+            </a:pPr>
+            <a:r>
+              <a:rPr lang="en-US" sz="1300" dirty="0">
+                <a:solidFill>
+                  <a:schemeClr val="tx1"/>
+                </a:solidFill>
+              </a:rPr>
+              <a:t>platform: Docker stack end to end, 14/14 smoke checks pass</a:t>
+            </a:r>
+            <a:endParaRPr lang="en-US" sz="1300" dirty="0"/>
+          </a:p>
+          <a:p>
+            <a:pPr marL="177800" indent="-177800">
+              <a:spcAft>
+                <a:spcPts val="600"/>
+              </a:spcAft>
+              <a:buSzPct val="100000"/>
+              <a:buChar char="•"/>
+            </a:pPr>
+            <a:r>
+              <a:rPr lang="en-US" sz="1300" dirty="0">
+                <a:solidFill>
+                  <a:schemeClr val="tx1"/>
+                </a:solidFill>
+              </a:rPr>
+              <a:t>deploy: build, test, publish the image</a:t>
+            </a:r>
+            <a:endParaRPr lang="en-US" sz="1300" dirty="0"/>
+          </a:p>
+        </p:txBody>
+      </p:sp>
+      <p:sp>
+        <p:nvSpPr>
+          <p:cNvPr id="9" name="card-33"/>
+          <p:cNvSpPr/>
+          <p:nvPr/>
+        </p:nvSpPr>
+        <p:spPr>
+          <a:xfrm>
+            <a:off x="6035040" y="1097280"/>
+            <a:ext cx="2606040" cy="3200400"/>
+          </a:xfrm>
+          <a:prstGeom prst="roundRect">
+            <a:avLst>
+              <a:gd name="adj" fmla="val 2807"/>
+            </a:avLst>
+          </a:prstGeom>
+          <a:solidFill>
+            <a:schemeClr val="bg2"/>
+          </a:solidFill>
+          <a:ln w="12700">
+            <a:solidFill>
+              <a:schemeClr val="bg2"/>
+            </a:solidFill>
+            <a:prstDash val="solid"/>
+          </a:ln>
+        </p:spPr>
+      </p:sp>
+      <p:sp>
+        <p:nvSpPr>
+          <p:cNvPr id="10" name="Text 8"/>
+          <p:cNvSpPr txBox="1"/>
+          <p:nvPr/>
+        </p:nvSpPr>
+        <p:spPr>
+          <a:xfrm>
+            <a:off x="6217920" y="1234440"/>
+            <a:ext cx="2240280" cy="365760"/>
+          </a:xfrm>
+          <a:prstGeom prst="rect">
+            <a:avLst/>
+          </a:prstGeom>
+          <a:noFill/>
+          <a:ln/>
+        </p:spPr>
+        <p:txBody>
+          <a:bodyPr wrap="square" lIns="0" tIns="0" rIns="0" bIns="0" rtlCol="0" anchor="t"/>
+          <a:lstStyle/>
+          <a:p>
+            <a:pPr indent="0" marL="0">
+              <a:buNone/>
+            </a:pPr>
+            <a:r>
+              <a:rPr lang="en-US" sz="1600" b="1" dirty="0">
+                <a:solidFill>
+                  <a:schemeClr val="accent1"/>
+                </a:solidFill>
+              </a:rPr>
+              <a:t>Quality</a:t>
+            </a:r>
+            <a:endParaRPr lang="en-US" sz="1600" dirty="0"/>
+          </a:p>
+        </p:txBody>
+      </p:sp>
+      <p:sp>
+        <p:nvSpPr>
+          <p:cNvPr id="11" name="Text 9"/>
+          <p:cNvSpPr txBox="1"/>
+          <p:nvPr/>
+        </p:nvSpPr>
+        <p:spPr>
+          <a:xfrm>
+            <a:off x="6217920" y="1691640"/>
+            <a:ext cx="2286000" cy="2468880"/>
+          </a:xfrm>
+          <a:prstGeom prst="rect">
+            <a:avLst/>
+          </a:prstGeom>
+          <a:noFill/>
+          <a:ln/>
+        </p:spPr>
+        <p:txBody>
+          <a:bodyPr wrap="square" lIns="0" tIns="0" rIns="0" bIns="0" rtlCol="0" anchor="t"/>
+          <a:lstStyle/>
+          <a:p>
+            <a:pPr marL="177800" indent="-177800">
+              <a:spcAft>
+                <a:spcPts val="600"/>
+              </a:spcAft>
+              <a:buSzPct val="100000"/>
+              <a:buChar char="•"/>
+            </a:pPr>
+            <a:r>
+              <a:rPr lang="en-US" sz="1300" dirty="0">
+                <a:solidFill>
+                  <a:schemeClr val="tx1"/>
+                </a:solidFill>
+              </a:rPr>
+              <a:t>56/56 verification checks pass</a:t>
+            </a:r>
+            <a:endParaRPr lang="en-US" sz="1300" dirty="0"/>
+          </a:p>
+          <a:p>
+            <a:pPr marL="177800" indent="-177800">
+              <a:spcAft>
+                <a:spcPts val="600"/>
+              </a:spcAft>
+              <a:buSzPct val="100000"/>
+              <a:buChar char="•"/>
+            </a:pPr>
+            <a:r>
+              <a:rPr lang="en-US" sz="1300" dirty="0">
+                <a:solidFill>
+                  <a:schemeClr val="tx1"/>
+                </a:solidFill>
+              </a:rPr>
+              <a:t>Train/serve parity test (caught a real bug)</a:t>
+            </a:r>
+            <a:endParaRPr lang="en-US" sz="1300" dirty="0"/>
+          </a:p>
+          <a:p>
+            <a:pPr marL="177800" indent="-177800">
+              <a:spcAft>
+                <a:spcPts val="600"/>
+              </a:spcAft>
+              <a:buSzPct val="100000"/>
+              <a:buChar char="•"/>
+            </a:pPr>
+            <a:r>
+              <a:rPr lang="en-US" sz="1300" dirty="0">
+                <a:solidFill>
+                  <a:schemeClr val="tx1"/>
+                </a:solidFill>
+              </a:rPr>
+              <a:t>Pinned versions, one-command rebuild</a:t>
+            </a:r>
+            <a:endParaRPr lang="en-US" sz="1300" dirty="0"/>
+          </a:p>
+        </p:txBody>
+      </p:sp>
+      <p:sp>
+        <p:nvSpPr>
+          <p:cNvPr id="25" name="Slide Number Placeholder 0"/>
+          <p:cNvSpPr>
+            <a:spLocks noGrp="1"/>
+          </p:cNvSpPr>
+          <p:nvPr>
+            <p:ph type="sldNum" sz="quarter" idx="4294967295"/>
+          </p:nvPr>
+        </p:nvSpPr>
+        <p:spPr>
+          <a:xfrm>
+            <a:off x="8412480" y="4800600"/>
+            <a:ext cx="457200" cy="228600"/>
+          </a:xfrm>
+          <a:prstGeom prst="rect">
+            <a:avLst/>
+          </a:prstGeom>
+          <a:extLst>
+            <a:ext uri="{C572A759-6A51-4108-AA02-DFA0A04FC94B}">
+              <ma14:wrappingTextBoxFlag xmlns:ma14="http://schemas.microsoft.com/office/mac/drawingml/2011/main" val="0"/>
+            </a:ext>
+          </a:extLst>
+        </p:spPr>
+        <p:txBody>
+          <a:bodyPr/>
+          <a:lstStyle>
+            <a:lvl1pPr>
+              <a:defRPr sz="900">
+                <a:solidFill>
+                  <a:schemeClr val="accent6"/>
+                </a:solidFill>
+              </a:defRPr>
+            </a:lvl1pPr>
+          </a:lstStyle>
+          <a:p>
+            <a:pPr algn="l"/>
+            <a:fld id="{F7021451-1387-4CA6-816F-3879F97B5CBC}" type="slidenum">
+              <a:rPr b="0" lang="en-US"/>
+              <a:t>13</a:t>
+            </a:fld>
+            <a:endParaRPr lang="en-US"/>
+          </a:p>
+        </p:txBody>
+      </p:sp>
+    </p:spTree>
+  </p:cSld>
+  <p:clrMapOvr>
+    <a:masterClrMapping/>
+  </p:clrMapOvr>
+</p:sld>
+</file>
+
+<file path=ppt/slides/slide14.xml><?xml version="1.0" encoding="utf-8"?>
+<p:sld xmlns:a="http://schemas.openxmlformats.org/drawingml/2006/main" xmlns:r="http://schemas.openxmlformats.org/officeDocument/2006/relationships" xmlns:p="http://schemas.openxmlformats.org/presentationml/2006/main">
+  <p:cSld name="Slide 14">
+    <p:spTree>
+      <p:nvGrpSpPr>
+        <p:cNvPr id="1" name=""/>
+        <p:cNvGrpSpPr/>
+        <p:nvPr/>
+      </p:nvGrpSpPr>
+      <p:grpSpPr>
+        <a:xfrm>
+          <a:off x="0" y="0"/>
+          <a:ext cx="0" cy="0"/>
+          <a:chOff x="0" y="0"/>
+          <a:chExt cx="0" cy="0"/>
+        </a:xfrm>
+      </p:grpSpPr>
+      <p:sp>
+        <p:nvSpPr>
+          <p:cNvPr id="2" name="Text 0"/>
+          <p:cNvSpPr/>
+          <p:nvPr>
+            <p:ph idx="100" type="title" hasCustomPrompt="1"/>
+          </p:nvPr>
+        </p:nvSpPr>
+        <p:spPr>
+          <a:xfrm>
             <a:off x="548640" y="640080"/>
             <a:ext cx="8046720" cy="1645920"/>
           </a:xfrm>
@@ -5847,7 +6682,7 @@
                   <a:schemeClr val="tx2"/>
                 </a:solidFill>
               </a:rPr>
-              <a:t>$964,182 net benefit</a:t>
+              <a:t>≈ $964,182 estimated net benefit</a:t>
             </a:r>
             <a:pPr indent="0" marL="0">
               <a:buNone/>
@@ -5858,7 +6693,7 @@
                   <a:schemeClr val="tx1"/>
                 </a:solidFill>
               </a:rPr>
-              <a:t> on the test period: 98.7% of fraud value caught, after $15 per review. All 56 end-to-end verification checks pass.</a:t>
+              <a:t> on the test period (98.7% of fraud value caught), assuming $15 per review and 90% recovery: an estimate on simulated data, not demonstrated savings. All 56 verification checks pass.</a:t>
             </a:r>
             <a:endParaRPr lang="en-US" sz="1500" dirty="0"/>
           </a:p>

</xml_diff>

<commit_message>
Record the 16-check platform run and the feedback items in the project plan
</commit_message>
<xml_diff>
--- a/deliverables/FraudLens_Final_Presentation.pptx
+++ b/deliverables/FraudLens_Final_Presentation.pptx
@@ -120,39 +120,39 @@
   <p:extLst>
     <p:ext uri="{521415D9-36F7-43E2-AB2F-B90AF26B5E84}">
       <p14:sectionLst xmlns:p14="http://schemas.microsoft.com/office/powerpoint/2010/main">
-        <p14:section name="Introduction" id="{dd48119a-b47d-00c1-c672-3dbf2897934b}">
+        <p14:section name="Introduction" id="{39b37316-416b-4a93-83af-58224546eebd}">
           <p14:sldIdLst>
             <p14:sldId id="256"/>
             <p14:sldId id="257"/>
           </p14:sldIdLst>
         </p14:section>
-        <p14:section name="Lifecycle" id="{e1af44ad-0133-8656-9a51-f51112441a9e}">
+        <p14:section name="Lifecycle" id="{cccab95d-096c-e06d-05b9-8d3a046ffecd}">
           <p14:sldIdLst>
             <p14:sldId id="258"/>
             <p14:sldId id="259"/>
           </p14:sldIdLst>
         </p14:section>
-        <p14:section name="Data" id="{7f094d91-b99d-5b9d-14aa-9d2888f43a4f}">
+        <p14:section name="Data" id="{216793c0-fd6f-863d-d673-181cb588bdbb}">
           <p14:sldIdLst>
             <p14:sldId id="260"/>
             <p14:sldId id="261"/>
           </p14:sldIdLst>
         </p14:section>
-        <p14:section name="Modelling" id="{39648895-9898-5f12-436f-83090ccdfe7a}">
+        <p14:section name="Modelling" id="{1703e28c-01e4-d02f-b565-77e10333786e}">
           <p14:sldIdLst>
             <p14:sldId id="262"/>
             <p14:sldId id="263"/>
             <p14:sldId id="264"/>
           </p14:sldIdLst>
         </p14:section>
-        <p14:section name="Deployment" id="{bd56bf68-97a7-2834-2af4-da6f4ca76afe}">
+        <p14:section name="Deployment" id="{dd4f8565-b739-5a69-ae70-f4a456e52ef4}">
           <p14:sldIdLst>
             <p14:sldId id="265"/>
             <p14:sldId id="266"/>
             <p14:sldId id="267"/>
           </p14:sldIdLst>
         </p14:section>
-        <p14:section name="Close" id="{d3d4c99e-2a51-df44-f8c8-c2b0f4e20a4e}">
+        <p14:section name="Close" id="{cfc0b0cb-37a8-8192-b9d6-810b5b2cb58f}">
           <p14:sldIdLst>
             <p14:sldId id="268"/>
             <p14:sldId id="269"/>
@@ -2619,7 +2619,7 @@
           <a:p>
             <a:r>
               <a:rPr lang="en-US" dirty="0"/>
-              <a:t>The project is run like a product. The GitHub Project board is generated from a plan file, with milestones and an issue per task, and a lifecycle-stage field so progress is visible stage by stage. Three workflows test the lifecycle, the whole Docker platform, and the deployable image. On the runner every platform service starts, the sample lifecycle flows from NiFi through the lake, Trino and ClickHouse, and 14 of 14 smoke checks pass; OpenMetadata catalogues 13 tables with 29 PII-tagged columns and lineage. Fifty-six verification checks pass, including a train-to-serve parity test that caught a real precision bug during the final run.</a:t>
+              <a:t>The project is run like a product. The GitHub Project board is generated from a plan file, with milestones and an issue per task, and a lifecycle-stage field so progress is visible stage by stage. Three workflows test the lifecycle, the whole Docker platform, and the deployable image. On the runner every platform service starts, the sample lifecycle flows from NiFi through the lake, Trino and ClickHouse, and 16 of 16 smoke checks pass; OpenMetadata catalogues 13 tables with 29 PII-tagged columns and lineage. Fifty-six verification checks pass, including a train-to-serve parity test that caught a real precision bug during the final run.</a:t>
             </a:r>
             <a:endParaRPr lang="en-US" dirty="0"/>
           </a:p>
@@ -5799,7 +5799,7 @@
                   <a:schemeClr val="tx1"/>
                 </a:solidFill>
               </a:rPr>
-              <a:t>platform: Docker stack end to end, 14/14 smoke checks pass</a:t>
+              <a:t>platform: Docker stack end to end, 16/16 smoke checks pass</a:t>
             </a:r>
             <a:endParaRPr lang="en-US" sz="1300" dirty="0"/>
           </a:p>

</xml_diff>